<commit_message>
Hook de Dani BOX: el profe antes que el horario
"Dani se sabe el nombre de cada alumno" sale de la seccion del profe de
la web. Engancha con el argumento: eso no se delega, los horarios si se
escriben una sola vez.

Co-Authored-By: Claude Opus 5 <noreply@anthropic.com>
</commit_message>
<xml_diff>
--- a/contenido/carruseles/04-danibox/editable-canva.pptx
+++ b/contenido/carruseles/04-danibox/editable-canva.pptx
@@ -3153,8 +3153,8 @@
         </p:nvSpPr>
         <p:spPr>
           <a:xfrm>
-            <a:off x="838200" y="7783907"/>
-            <a:ext cx="4553247" cy="315468"/>
+            <a:off x="838200" y="7336976"/>
+            <a:ext cx="4837211" cy="315468"/>
           </a:xfrm>
           <a:prstGeom prst="rect">
             <a:avLst/>
@@ -3197,8 +3197,8 @@
         </p:nvSpPr>
         <p:spPr>
           <a:xfrm>
-            <a:off x="838200" y="4446686"/>
-            <a:ext cx="9182100" cy="3651051"/>
+            <a:off x="838200" y="4893468"/>
+            <a:ext cx="9182100" cy="2757338"/>
           </a:xfrm>
           <a:prstGeom prst="rect">
             <a:avLst/>
@@ -3223,7 +3223,7 @@
                 </a:solidFill>
                 <a:latin typeface="Bricolage Grotesque"/>
               </a:rPr>
-              <a:t xml:space="preserve">En un gimnasio</a:t>
+              <a:t xml:space="preserve">Dani se sabe</a:t>
             </a:r>
           </a:p>
           <a:p>
@@ -3239,7 +3239,7 @@
                 </a:solidFill>
                 <a:latin typeface="Bricolage Grotesque"/>
               </a:rPr>
-              <a:t xml:space="preserve">siempre preguntan</a:t>
+              <a:t xml:space="preserve">el nombre de</a:t>
             </a:r>
           </a:p>
           <a:p>
@@ -3255,15 +3255,8 @@
                 </a:solidFill>
                 <a:latin typeface="Bricolage Grotesque"/>
               </a:rPr>
-              <a:t xml:space="preserve">lo mismo:</a:t>
-            </a:r>
-          </a:p>
-          <a:p>
-            <a:pPr algn="l">
-              <a:lnSpc>
-                <a:spcPts val="7038"/>
-              </a:lnSpc>
-            </a:pPr>
+              <a:t xml:space="preserve">cada alumno</a:t>
+            </a:r>
             <a:r>
               <a:rPr sz="6900" b="1" spc="-206">
                 <a:solidFill>
@@ -3271,7 +3264,7 @@
                 </a:solidFill>
                 <a:latin typeface="Bricolage Grotesque"/>
               </a:rPr>
-              <a:t xml:space="preserve">¿a qué hora?</a:t>
+              <a:t xml:space="preserve">.</a:t>
             </a:r>
           </a:p>
         </p:txBody>

</xml_diff>

<commit_message>
Hook B: 26 anos ensenando en el mismo lugar
Mateo confirma 26, no 25. La web de Dani BOX todavia dice 25 en el hero
y en la seccion del profe: hay que corregirla.

Co-Authored-By: Claude Opus 5 <noreply@anthropic.com>
</commit_message>
<xml_diff>
--- a/contenido/carruseles/04-danibox/editable-canva.pptx
+++ b/contenido/carruseles/04-danibox/editable-canva.pptx
@@ -3153,8 +3153,8 @@
         </p:nvSpPr>
         <p:spPr>
           <a:xfrm>
-            <a:off x="838200" y="7336976"/>
-            <a:ext cx="4837211" cy="315468"/>
+            <a:off x="2678459" y="7336976"/>
+            <a:ext cx="4648795" cy="315468"/>
           </a:xfrm>
           <a:prstGeom prst="rect">
             <a:avLst/>
@@ -3223,7 +3223,7 @@
                 </a:solidFill>
                 <a:latin typeface="Bricolage Grotesque"/>
               </a:rPr>
-              <a:t xml:space="preserve">Dani se sabe</a:t>
+              <a:t xml:space="preserve">Hace 26 años</a:t>
             </a:r>
           </a:p>
           <a:p>
@@ -3239,7 +3239,7 @@
                 </a:solidFill>
                 <a:latin typeface="Bricolage Grotesque"/>
               </a:rPr>
-              <a:t xml:space="preserve">el nombre de</a:t>
+              <a:t xml:space="preserve">que Dani enseña</a:t>
             </a:r>
           </a:p>
           <a:p>
@@ -3255,7 +3255,16 @@
                 </a:solidFill>
                 <a:latin typeface="Bricolage Grotesque"/>
               </a:rPr>
-              <a:t xml:space="preserve">cada alumno</a:t>
+              <a:t xml:space="preserve">en el </a:t>
+            </a:r>
+            <a:r>
+              <a:rPr sz="6900" b="1" spc="-206">
+                <a:solidFill>
+                  <a:srgbClr val="0A1B33"/>
+                </a:solidFill>
+                <a:latin typeface="Bricolage Grotesque"/>
+              </a:rPr>
+              <a:t xml:space="preserve">mismo lugar</a:t>
             </a:r>
             <a:r>
               <a:rPr sz="6900" b="1" spc="-206">

</xml_diff>

<commit_message>
Slide 2 de Dani BOX: el dato gigante ahora va con una parte de la web
El dato entra al lado de una captura (210px en vez de 320). Se cambio el
16 por el 4,4 de Google con la captura de las opiniones: la franja de
estadisticas del sitio dice 25 anos y el carrusel dice 26.

Co-Authored-By: Claude Opus 5 <noreply@anthropic.com>
</commit_message>
<xml_diff>
--- a/contenido/carruseles/04-danibox/editable-canva.pptx
+++ b/contenido/carruseles/04-danibox/editable-canva.pptx
@@ -3477,6 +3477,30 @@
         </p:blipFill>
         <p:spPr>
           <a:xfrm>
+            <a:off x="6019800" y="2909887"/>
+            <a:ext cx="3429000" cy="6858000"/>
+          </a:xfrm>
+          <a:prstGeom prst="rect">
+            <a:avLst/>
+          </a:prstGeom>
+        </p:spPr>
+      </p:pic>
+      <p:pic>
+        <p:nvPicPr>
+          <p:cNvPr id="5" name="Picture 4" descr="image.png"/>
+          <p:cNvPicPr>
+            <a:picLocks noChangeAspect="1"/>
+          </p:cNvPicPr>
+          <p:nvPr/>
+        </p:nvPicPr>
+        <p:blipFill>
+          <a:blip r:embed="rId3"/>
+          <a:stretch>
+            <a:fillRect/>
+          </a:stretch>
+        </p:blipFill>
+        <p:spPr>
+          <a:xfrm>
             <a:off x="838200" y="11582400"/>
             <a:ext cx="438150" cy="438150"/>
           </a:xfrm>
@@ -3487,7 +3511,7 @@
       </p:pic>
       <p:sp>
         <p:nvSpPr>
-          <p:cNvPr id="5" name="TextBox 4"/>
+          <p:cNvPr id="6" name="TextBox 5"/>
           <p:cNvSpPr txBox="1"/>
           <p:nvPr/>
         </p:nvSpPr>

</xml_diff>

<commit_message>
Hook: el titular del hero de la web de Dani BOX
"Aca se aprende a boxear y a bancar al de al lado". Los anos vuelven a
25, como dice el sitio, hasta que Dani confirme.

Co-Authored-By: Claude Opus 5 <noreply@anthropic.com>
</commit_message>
<xml_diff>
--- a/contenido/carruseles/04-danibox/editable-canva.pptx
+++ b/contenido/carruseles/04-danibox/editable-canva.pptx
@@ -3153,8 +3153,8 @@
         </p:nvSpPr>
         <p:spPr>
           <a:xfrm>
-            <a:off x="2678459" y="7336976"/>
-            <a:ext cx="4648795" cy="315468"/>
+            <a:off x="838200" y="6890194"/>
+            <a:ext cx="4572595" cy="315468"/>
           </a:xfrm>
           <a:prstGeom prst="rect">
             <a:avLst/>
@@ -3191,14 +3191,58 @@
       </p:sp>
       <p:sp>
         <p:nvSpPr>
-          <p:cNvPr id="4" name="TextBox 3"/>
+          <p:cNvPr id="4" name="Rectangle 3"/>
+          <p:cNvSpPr/>
+          <p:nvPr/>
+        </p:nvSpPr>
+        <p:spPr>
+          <a:xfrm>
+            <a:off x="838200" y="7783907"/>
+            <a:ext cx="2464147" cy="315468"/>
+          </a:xfrm>
+          <a:prstGeom prst="rect">
+            <a:avLst/>
+          </a:prstGeom>
+          <a:solidFill>
+            <a:srgbClr val="A8E1F8"/>
+          </a:solidFill>
+          <a:ln>
+            <a:noFill/>
+          </a:ln>
+          <a:effectLst/>
+        </p:spPr>
+        <p:style>
+          <a:lnRef idx="1">
+            <a:schemeClr val="accent1"/>
+          </a:lnRef>
+          <a:fillRef idx="3">
+            <a:schemeClr val="accent1"/>
+          </a:fillRef>
+          <a:effectRef idx="2">
+            <a:schemeClr val="accent1"/>
+          </a:effectRef>
+          <a:fontRef idx="minor">
+            <a:schemeClr val="lt1"/>
+          </a:fontRef>
+        </p:style>
+        <p:txBody>
+          <a:bodyPr rtlCol="0" anchor="ctr"/>
+          <a:lstStyle/>
+          <a:p>
+            <a:pPr algn="ctr"/>
+          </a:p>
+        </p:txBody>
+      </p:sp>
+      <p:sp>
+        <p:nvSpPr>
+          <p:cNvPr id="5" name="TextBox 4"/>
           <p:cNvSpPr txBox="1"/>
           <p:nvPr/>
         </p:nvSpPr>
         <p:spPr>
           <a:xfrm>
-            <a:off x="838200" y="4893468"/>
-            <a:ext cx="9182100" cy="2757338"/>
+            <a:off x="838200" y="4446686"/>
+            <a:ext cx="9182100" cy="3651051"/>
           </a:xfrm>
           <a:prstGeom prst="rect">
             <a:avLst/>
@@ -3223,7 +3267,7 @@
                 </a:solidFill>
                 <a:latin typeface="Bricolage Grotesque"/>
               </a:rPr>
-              <a:t xml:space="preserve">Hace 26 años</a:t>
+              <a:t xml:space="preserve">Acá se aprende</a:t>
             </a:r>
           </a:p>
           <a:p>
@@ -3239,7 +3283,7 @@
                 </a:solidFill>
                 <a:latin typeface="Bricolage Grotesque"/>
               </a:rPr>
-              <a:t xml:space="preserve">que Dani enseña</a:t>
+              <a:t xml:space="preserve">a boxear y a</a:t>
             </a:r>
           </a:p>
           <a:p>
@@ -3255,8 +3299,15 @@
                 </a:solidFill>
                 <a:latin typeface="Bricolage Grotesque"/>
               </a:rPr>
-              <a:t xml:space="preserve">en el </a:t>
-            </a:r>
+              <a:t xml:space="preserve">bancar al de</a:t>
+            </a:r>
+          </a:p>
+          <a:p>
+            <a:pPr algn="l">
+              <a:lnSpc>
+                <a:spcPts val="7038"/>
+              </a:lnSpc>
+            </a:pPr>
             <a:r>
               <a:rPr sz="6900" b="1" spc="-206">
                 <a:solidFill>
@@ -3264,7 +3315,7 @@
                 </a:solidFill>
                 <a:latin typeface="Bricolage Grotesque"/>
               </a:rPr>
-              <a:t xml:space="preserve">mismo lugar</a:t>
+              <a:t xml:space="preserve">al lado</a:t>
             </a:r>
             <a:r>
               <a:rPr sz="6900" b="1" spc="-206">
@@ -3280,7 +3331,7 @@
       </p:sp>
       <p:pic>
         <p:nvPicPr>
-          <p:cNvPr id="5" name="Picture 4" descr="image.png"/>
+          <p:cNvPr id="6" name="Picture 5" descr="image.png"/>
           <p:cNvPicPr>
             <a:picLocks noChangeAspect="1"/>
           </p:cNvPicPr>
@@ -3304,7 +3355,7 @@
       </p:pic>
       <p:sp>
         <p:nvSpPr>
-          <p:cNvPr id="6" name="TextBox 5"/>
+          <p:cNvPr id="7" name="TextBox 6"/>
           <p:cNvSpPr txBox="1"/>
           <p:nvPr/>
         </p:nvSpPr>

</xml_diff>

<commit_message>
El PPTX exporta los bloques nuevos: foto de fondo, dato y captura anotada
Canva mostraba paginas vacias porque pptx_export.py solo conocia los
bloques viejos. Se suman .bgimg (primero de todo, para que quede abajo),
.dato/.dato-txt/.dato-pie, el guion y los dos textos de cada nota, y la
captura grande. El titulo de cada nota va en su propio span: sin eso el
titulo y la aclaracion caian en el mismo renglon.

Co-Authored-By: Claude Opus 5 <noreply@anthropic.com>
</commit_message>
<xml_diff>
--- a/contenido/carruseles/04-danibox/editable-canva.pptx
+++ b/contenido/carruseles/04-danibox/editable-canva.pptx
@@ -3099,9 +3099,33 @@
         <p:nvPr/>
       </p:nvGrpSpPr>
       <p:grpSpPr/>
-      <p:sp>
-        <p:nvSpPr>
-          <p:cNvPr id="2" name="Rounded Rectangle 1"/>
+      <p:pic>
+        <p:nvPicPr>
+          <p:cNvPr id="2" name="Picture 1" descr="image.png"/>
+          <p:cNvPicPr>
+            <a:picLocks noChangeAspect="1"/>
+          </p:cNvPicPr>
+          <p:nvPr/>
+        </p:nvPicPr>
+        <p:blipFill>
+          <a:blip r:embed="rId2"/>
+          <a:stretch>
+            <a:fillRect/>
+          </a:stretch>
+        </p:blipFill>
+        <p:spPr>
+          <a:xfrm>
+            <a:off x="-838200" y="-838200"/>
+            <a:ext cx="11963400" cy="14535150"/>
+          </a:xfrm>
+          <a:prstGeom prst="rect">
+            <a:avLst/>
+          </a:prstGeom>
+        </p:spPr>
+      </p:pic>
+      <p:sp>
+        <p:nvSpPr>
+          <p:cNvPr id="3" name="Rounded Rectangle 2"/>
           <p:cNvSpPr/>
           <p:nvPr/>
         </p:nvSpPr>
@@ -3147,7 +3171,7 @@
       </p:sp>
       <p:sp>
         <p:nvSpPr>
-          <p:cNvPr id="3" name="Rectangle 2"/>
+          <p:cNvPr id="4" name="Rectangle 3"/>
           <p:cNvSpPr/>
           <p:nvPr/>
         </p:nvSpPr>
@@ -3191,7 +3215,7 @@
       </p:sp>
       <p:sp>
         <p:nvSpPr>
-          <p:cNvPr id="4" name="TextBox 3"/>
+          <p:cNvPr id="5" name="TextBox 4"/>
           <p:cNvSpPr txBox="1"/>
           <p:nvPr/>
         </p:nvSpPr>
@@ -3280,14 +3304,14 @@
       </p:sp>
       <p:pic>
         <p:nvPicPr>
-          <p:cNvPr id="5" name="Picture 4" descr="image.png"/>
+          <p:cNvPr id="6" name="Picture 5" descr="image.png"/>
           <p:cNvPicPr>
             <a:picLocks noChangeAspect="1"/>
           </p:cNvPicPr>
           <p:nvPr/>
         </p:nvPicPr>
         <p:blipFill>
-          <a:blip r:embed="rId2"/>
+          <a:blip r:embed="rId3"/>
           <a:stretch>
             <a:fillRect/>
           </a:stretch>
@@ -3304,7 +3328,7 @@
       </p:pic>
       <p:sp>
         <p:nvSpPr>
-          <p:cNvPr id="6" name="TextBox 5"/>
+          <p:cNvPr id="7" name="TextBox 6"/>
           <p:cNvSpPr txBox="1"/>
           <p:nvPr/>
         </p:nvSpPr>
@@ -3461,9 +3485,142 @@
           </a:p>
         </p:txBody>
       </p:sp>
+      <p:sp>
+        <p:nvSpPr>
+          <p:cNvPr id="4" name="TextBox 3"/>
+          <p:cNvSpPr txBox="1"/>
+          <p:nvPr/>
+        </p:nvSpPr>
+        <p:spPr>
+          <a:xfrm>
+            <a:off x="838200" y="4267051"/>
+            <a:ext cx="5181600" cy="1796355"/>
+          </a:xfrm>
+          <a:prstGeom prst="rect">
+            <a:avLst/>
+          </a:prstGeom>
+          <a:noFill/>
+        </p:spPr>
+        <p:txBody>
+          <a:bodyPr wrap="none" lIns="0" rIns="0" tIns="0" bIns="0" anchor="t">
+            <a:noAutofit/>
+          </a:bodyPr>
+          <a:lstStyle/>
+          <a:p>
+            <a:pPr algn="l">
+              <a:lnSpc>
+                <a:spcPts val="13544"/>
+              </a:lnSpc>
+            </a:pPr>
+            <a:r>
+              <a:rPr sz="15750" b="1" spc="-787">
+                <a:solidFill>
+                  <a:srgbClr val="63C8F2"/>
+                </a:solidFill>
+                <a:latin typeface="Bricolage Grotesque"/>
+              </a:rPr>
+              <a:t xml:space="preserve">4,4</a:t>
+            </a:r>
+          </a:p>
+        </p:txBody>
+      </p:sp>
+      <p:sp>
+        <p:nvSpPr>
+          <p:cNvPr id="5" name="TextBox 4"/>
+          <p:cNvSpPr txBox="1"/>
+          <p:nvPr/>
+        </p:nvSpPr>
+        <p:spPr>
+          <a:xfrm>
+            <a:off x="838200" y="6234856"/>
+            <a:ext cx="5181600" cy="981372"/>
+          </a:xfrm>
+          <a:prstGeom prst="rect">
+            <a:avLst/>
+          </a:prstGeom>
+          <a:noFill/>
+        </p:spPr>
+        <p:txBody>
+          <a:bodyPr wrap="none" lIns="0" rIns="0" tIns="0" bIns="0" anchor="t">
+            <a:noAutofit/>
+          </a:bodyPr>
+          <a:lstStyle/>
+          <a:p>
+            <a:pPr algn="l">
+              <a:lnSpc>
+                <a:spcPts val="3564"/>
+              </a:lnSpc>
+            </a:pPr>
+            <a:r>
+              <a:rPr sz="3300" b="1" spc="-66">
+                <a:solidFill>
+                  <a:srgbClr val="FFFFFF"/>
+                </a:solidFill>
+                <a:latin typeface="Bricolage Grotesque"/>
+              </a:rPr>
+              <a:t xml:space="preserve">de puntaje</a:t>
+            </a:r>
+          </a:p>
+          <a:p>
+            <a:pPr algn="l">
+              <a:lnSpc>
+                <a:spcPts val="3564"/>
+              </a:lnSpc>
+            </a:pPr>
+            <a:r>
+              <a:rPr sz="3300" b="1" spc="-66">
+                <a:solidFill>
+                  <a:srgbClr val="FFFFFF"/>
+                </a:solidFill>
+                <a:latin typeface="Bricolage Grotesque"/>
+              </a:rPr>
+              <a:t xml:space="preserve">en Google.</a:t>
+            </a:r>
+          </a:p>
+        </p:txBody>
+      </p:sp>
+      <p:sp>
+        <p:nvSpPr>
+          <p:cNvPr id="6" name="TextBox 5"/>
+          <p:cNvSpPr txBox="1"/>
+          <p:nvPr/>
+        </p:nvSpPr>
+        <p:spPr>
+          <a:xfrm>
+            <a:off x="838200" y="7330529"/>
+            <a:ext cx="4667250" cy="1156245"/>
+          </a:xfrm>
+          <a:prstGeom prst="rect">
+            <a:avLst/>
+          </a:prstGeom>
+          <a:noFill/>
+        </p:spPr>
+        <p:txBody>
+          <a:bodyPr wrap="square" lIns="0" rIns="0" tIns="0" bIns="0" anchor="t">
+            <a:noAutofit/>
+          </a:bodyPr>
+          <a:lstStyle/>
+          <a:p>
+            <a:pPr algn="l">
+              <a:lnSpc>
+                <a:spcPts val="2835"/>
+              </a:lnSpc>
+            </a:pPr>
+            <a:r>
+              <a:rPr sz="2025" b="0">
+                <a:solidFill>
+                  <a:srgbClr val="B9CFE8"/>
+                </a:solidFill>
+                <a:latin typeface="Figtree"/>
+              </a:rPr>
+              <a:t xml:space="preserve">Las opiniones de los alumnos van en la web copiadas tal cual, con nombre y con el lugar donde las escribieron.</a:t>
+            </a:r>
+          </a:p>
+        </p:txBody>
+      </p:sp>
       <p:pic>
         <p:nvPicPr>
-          <p:cNvPr id="4" name="Picture 3" descr="image.png"/>
+          <p:cNvPr id="7" name="Picture 6" descr="image.png"/>
           <p:cNvPicPr>
             <a:picLocks noChangeAspect="1"/>
           </p:cNvPicPr>
@@ -3487,7 +3644,7 @@
       </p:pic>
       <p:pic>
         <p:nvPicPr>
-          <p:cNvPr id="5" name="Picture 4" descr="image.png"/>
+          <p:cNvPr id="8" name="Picture 7" descr="image.png"/>
           <p:cNvPicPr>
             <a:picLocks noChangeAspect="1"/>
           </p:cNvPicPr>
@@ -3511,7 +3668,7 @@
       </p:pic>
       <p:sp>
         <p:nvSpPr>
-          <p:cNvPr id="6" name="TextBox 5"/>
+          <p:cNvPr id="9" name="TextBox 8"/>
           <p:cNvSpPr txBox="1"/>
           <p:nvPr/>
         </p:nvSpPr>
@@ -3668,9 +3825,381 @@
           </a:p>
         </p:txBody>
       </p:sp>
+      <p:sp>
+        <p:nvSpPr>
+          <p:cNvPr id="4" name="Rounded Rectangle 3"/>
+          <p:cNvSpPr/>
+          <p:nvPr/>
+        </p:nvSpPr>
+        <p:spPr>
+          <a:xfrm>
+            <a:off x="5638800" y="3150840"/>
+            <a:ext cx="495300" cy="38100"/>
+          </a:xfrm>
+          <a:prstGeom prst="roundRect">
+            <a:avLst>
+              <a:gd name="adj" fmla="val 50000"/>
+            </a:avLst>
+          </a:prstGeom>
+          <a:solidFill>
+            <a:srgbClr val="00A8E8"/>
+          </a:solidFill>
+          <a:ln>
+            <a:noFill/>
+          </a:ln>
+          <a:effectLst/>
+        </p:spPr>
+        <p:style>
+          <a:lnRef idx="1">
+            <a:schemeClr val="accent1"/>
+          </a:lnRef>
+          <a:fillRef idx="3">
+            <a:schemeClr val="accent1"/>
+          </a:fillRef>
+          <a:effectRef idx="2">
+            <a:schemeClr val="accent1"/>
+          </a:effectRef>
+          <a:fontRef idx="minor">
+            <a:schemeClr val="lt1"/>
+          </a:fontRef>
+        </p:style>
+        <p:txBody>
+          <a:bodyPr rtlCol="0" anchor="ctr"/>
+          <a:lstStyle/>
+          <a:p>
+            <a:pPr algn="ctr"/>
+          </a:p>
+        </p:txBody>
+      </p:sp>
+      <p:sp>
+        <p:nvSpPr>
+          <p:cNvPr id="5" name="Rounded Rectangle 4"/>
+          <p:cNvSpPr/>
+          <p:nvPr/>
+        </p:nvSpPr>
+        <p:spPr>
+          <a:xfrm>
+            <a:off x="5638800" y="5476279"/>
+            <a:ext cx="495300" cy="38100"/>
+          </a:xfrm>
+          <a:prstGeom prst="roundRect">
+            <a:avLst>
+              <a:gd name="adj" fmla="val 50000"/>
+            </a:avLst>
+          </a:prstGeom>
+          <a:solidFill>
+            <a:srgbClr val="00A8E8"/>
+          </a:solidFill>
+          <a:ln>
+            <a:noFill/>
+          </a:ln>
+          <a:effectLst/>
+        </p:spPr>
+        <p:style>
+          <a:lnRef idx="1">
+            <a:schemeClr val="accent1"/>
+          </a:lnRef>
+          <a:fillRef idx="3">
+            <a:schemeClr val="accent1"/>
+          </a:fillRef>
+          <a:effectRef idx="2">
+            <a:schemeClr val="accent1"/>
+          </a:effectRef>
+          <a:fontRef idx="minor">
+            <a:schemeClr val="lt1"/>
+          </a:fontRef>
+        </p:style>
+        <p:txBody>
+          <a:bodyPr rtlCol="0" anchor="ctr"/>
+          <a:lstStyle/>
+          <a:p>
+            <a:pPr algn="ctr"/>
+          </a:p>
+        </p:txBody>
+      </p:sp>
+      <p:sp>
+        <p:nvSpPr>
+          <p:cNvPr id="6" name="Rounded Rectangle 5"/>
+          <p:cNvSpPr/>
+          <p:nvPr/>
+        </p:nvSpPr>
+        <p:spPr>
+          <a:xfrm>
+            <a:off x="5638800" y="8125717"/>
+            <a:ext cx="495300" cy="38100"/>
+          </a:xfrm>
+          <a:prstGeom prst="roundRect">
+            <a:avLst>
+              <a:gd name="adj" fmla="val 50000"/>
+            </a:avLst>
+          </a:prstGeom>
+          <a:solidFill>
+            <a:srgbClr val="00A8E8"/>
+          </a:solidFill>
+          <a:ln>
+            <a:noFill/>
+          </a:ln>
+          <a:effectLst/>
+        </p:spPr>
+        <p:style>
+          <a:lnRef idx="1">
+            <a:schemeClr val="accent1"/>
+          </a:lnRef>
+          <a:fillRef idx="3">
+            <a:schemeClr val="accent1"/>
+          </a:fillRef>
+          <a:effectRef idx="2">
+            <a:schemeClr val="accent1"/>
+          </a:effectRef>
+          <a:fontRef idx="minor">
+            <a:schemeClr val="lt1"/>
+          </a:fontRef>
+        </p:style>
+        <p:txBody>
+          <a:bodyPr rtlCol="0" anchor="ctr"/>
+          <a:lstStyle/>
+          <a:p>
+            <a:pPr algn="ctr"/>
+          </a:p>
+        </p:txBody>
+      </p:sp>
+      <p:sp>
+        <p:nvSpPr>
+          <p:cNvPr id="7" name="TextBox 6"/>
+          <p:cNvSpPr txBox="1"/>
+          <p:nvPr/>
+        </p:nvSpPr>
+        <p:spPr>
+          <a:xfrm>
+            <a:off x="6324600" y="2979390"/>
+            <a:ext cx="3181350" cy="820042"/>
+          </a:xfrm>
+          <a:prstGeom prst="rect">
+            <a:avLst/>
+          </a:prstGeom>
+          <a:noFill/>
+        </p:spPr>
+        <p:txBody>
+          <a:bodyPr wrap="square" lIns="0" rIns="0" tIns="0" bIns="0" anchor="t">
+            <a:noAutofit/>
+          </a:bodyPr>
+          <a:lstStyle/>
+          <a:p>
+            <a:pPr algn="l">
+              <a:lnSpc>
+                <a:spcPts val="2929"/>
+              </a:lnSpc>
+            </a:pPr>
+            <a:r>
+              <a:rPr sz="2325" b="1">
+                <a:solidFill>
+                  <a:srgbClr val="0A1B33"/>
+                </a:solidFill>
+                <a:latin typeface="Figtree"/>
+              </a:rPr>
+              <a:t xml:space="preserve">Los 16 turnos, día por día</a:t>
+            </a:r>
+          </a:p>
+        </p:txBody>
+      </p:sp>
+      <p:sp>
+        <p:nvSpPr>
+          <p:cNvPr id="8" name="TextBox 7"/>
+          <p:cNvSpPr txBox="1"/>
+          <p:nvPr/>
+        </p:nvSpPr>
+        <p:spPr>
+          <a:xfrm>
+            <a:off x="6324600" y="5304829"/>
+            <a:ext cx="3181350" cy="820042"/>
+          </a:xfrm>
+          <a:prstGeom prst="rect">
+            <a:avLst/>
+          </a:prstGeom>
+          <a:noFill/>
+        </p:spPr>
+        <p:txBody>
+          <a:bodyPr wrap="square" lIns="0" rIns="0" tIns="0" bIns="0" anchor="t">
+            <a:noAutofit/>
+          </a:bodyPr>
+          <a:lstStyle/>
+          <a:p>
+            <a:pPr algn="l">
+              <a:lnSpc>
+                <a:spcPts val="2929"/>
+              </a:lnSpc>
+            </a:pPr>
+            <a:r>
+              <a:rPr sz="2325" b="1">
+                <a:solidFill>
+                  <a:srgbClr val="0A1B33"/>
+                </a:solidFill>
+                <a:latin typeface="Figtree"/>
+              </a:rPr>
+              <a:t xml:space="preserve">Cinco accesos a WhatsApp</a:t>
+            </a:r>
+          </a:p>
+        </p:txBody>
+      </p:sp>
+      <p:sp>
+        <p:nvSpPr>
+          <p:cNvPr id="9" name="TextBox 8"/>
+          <p:cNvSpPr txBox="1"/>
+          <p:nvPr/>
+        </p:nvSpPr>
+        <p:spPr>
+          <a:xfrm>
+            <a:off x="6324600" y="7954267"/>
+            <a:ext cx="3181350" cy="448121"/>
+          </a:xfrm>
+          <a:prstGeom prst="rect">
+            <a:avLst/>
+          </a:prstGeom>
+          <a:noFill/>
+        </p:spPr>
+        <p:txBody>
+          <a:bodyPr wrap="square" lIns="0" rIns="0" tIns="0" bIns="0" anchor="t">
+            <a:noAutofit/>
+          </a:bodyPr>
+          <a:lstStyle/>
+          <a:p>
+            <a:pPr algn="l">
+              <a:lnSpc>
+                <a:spcPts val="2929"/>
+              </a:lnSpc>
+            </a:pPr>
+            <a:r>
+              <a:rPr sz="2325" b="1">
+                <a:solidFill>
+                  <a:srgbClr val="0A1B33"/>
+                </a:solidFill>
+                <a:latin typeface="Figtree"/>
+              </a:rPr>
+              <a:t xml:space="preserve">También lo que no hay</a:t>
+            </a:r>
+          </a:p>
+        </p:txBody>
+      </p:sp>
+      <p:sp>
+        <p:nvSpPr>
+          <p:cNvPr id="10" name="TextBox 9"/>
+          <p:cNvSpPr txBox="1"/>
+          <p:nvPr/>
+        </p:nvSpPr>
+        <p:spPr>
+          <a:xfrm>
+            <a:off x="6324600" y="3799433"/>
+            <a:ext cx="3181350" cy="1048196"/>
+          </a:xfrm>
+          <a:prstGeom prst="rect">
+            <a:avLst/>
+          </a:prstGeom>
+          <a:noFill/>
+        </p:spPr>
+        <p:txBody>
+          <a:bodyPr wrap="square" lIns="0" rIns="0" tIns="0" bIns="0" anchor="t">
+            <a:noAutofit/>
+          </a:bodyPr>
+          <a:lstStyle/>
+          <a:p>
+            <a:pPr algn="l">
+              <a:lnSpc>
+                <a:spcPts val="2551"/>
+              </a:lnSpc>
+            </a:pPr>
+            <a:r>
+              <a:rPr sz="2025" b="0">
+                <a:solidFill>
+                  <a:srgbClr val="46526B"/>
+                </a:solidFill>
+                <a:latin typeface="Figtree"/>
+              </a:rPr>
+              <a:t xml:space="preserve">Con la hora de inicio y la de fin. Cada uno dura una hora y media.</a:t>
+            </a:r>
+          </a:p>
+        </p:txBody>
+      </p:sp>
+      <p:sp>
+        <p:nvSpPr>
+          <p:cNvPr id="11" name="TextBox 10"/>
+          <p:cNvSpPr txBox="1"/>
+          <p:nvPr/>
+        </p:nvSpPr>
+        <p:spPr>
+          <a:xfrm>
+            <a:off x="6324600" y="6124872"/>
+            <a:ext cx="3181350" cy="1372195"/>
+          </a:xfrm>
+          <a:prstGeom prst="rect">
+            <a:avLst/>
+          </a:prstGeom>
+          <a:noFill/>
+        </p:spPr>
+        <p:txBody>
+          <a:bodyPr wrap="square" lIns="0" rIns="0" tIns="0" bIns="0" anchor="t">
+            <a:noAutofit/>
+          </a:bodyPr>
+          <a:lstStyle/>
+          <a:p>
+            <a:pPr algn="l">
+              <a:lnSpc>
+                <a:spcPts val="2551"/>
+              </a:lnSpc>
+            </a:pPr>
+            <a:r>
+              <a:rPr sz="2025" b="0">
+                <a:solidFill>
+                  <a:srgbClr val="46526B"/>
+                </a:solidFill>
+                <a:latin typeface="Figtree"/>
+              </a:rPr>
+              <a:t xml:space="preserve">Cada uno con el mensaje ya escrito: probar una clase, elegir turno, sumarse a entrenar.</a:t>
+            </a:r>
+          </a:p>
+        </p:txBody>
+      </p:sp>
+      <p:sp>
+        <p:nvSpPr>
+          <p:cNvPr id="12" name="TextBox 11"/>
+          <p:cNvSpPr txBox="1"/>
+          <p:nvPr/>
+        </p:nvSpPr>
+        <p:spPr>
+          <a:xfrm>
+            <a:off x="6324600" y="8402389"/>
+            <a:ext cx="3181350" cy="1372195"/>
+          </a:xfrm>
+          <a:prstGeom prst="rect">
+            <a:avLst/>
+          </a:prstGeom>
+          <a:noFill/>
+        </p:spPr>
+        <p:txBody>
+          <a:bodyPr wrap="square" lIns="0" rIns="0" tIns="0" bIns="0" anchor="t">
+            <a:noAutofit/>
+          </a:bodyPr>
+          <a:lstStyle/>
+          <a:p>
+            <a:pPr algn="l">
+              <a:lnSpc>
+                <a:spcPts val="2551"/>
+              </a:lnSpc>
+            </a:pPr>
+            <a:r>
+              <a:rPr sz="2025" b="0">
+                <a:solidFill>
+                  <a:srgbClr val="46526B"/>
+                </a:solidFill>
+                <a:latin typeface="Figtree"/>
+              </a:rPr>
+              <a:t xml:space="preserve">Sábado y domingo dice “sin clases”, para que nadie llegue y encuentre todo cerrado.</a:t>
+            </a:r>
+          </a:p>
+        </p:txBody>
+      </p:sp>
       <p:pic>
         <p:nvPicPr>
-          <p:cNvPr id="4" name="Picture 3" descr="image.png"/>
+          <p:cNvPr id="13" name="Picture 12" descr="image.png"/>
           <p:cNvPicPr>
             <a:picLocks noChangeAspect="1"/>
           </p:cNvPicPr>
@@ -3684,17 +4213,41 @@
         </p:blipFill>
         <p:spPr>
           <a:xfrm>
-            <a:off x="838200" y="11582400"/>
-            <a:ext cx="438150" cy="438150"/>
+            <a:off x="674515" y="1954124"/>
+            <a:ext cx="4632668" cy="8769525"/>
           </a:xfrm>
           <a:prstGeom prst="rect">
             <a:avLst/>
           </a:prstGeom>
         </p:spPr>
       </p:pic>
-      <p:sp>
-        <p:nvSpPr>
-          <p:cNvPr id="5" name="TextBox 4"/>
+      <p:pic>
+        <p:nvPicPr>
+          <p:cNvPr id="14" name="Picture 13" descr="image.png"/>
+          <p:cNvPicPr>
+            <a:picLocks noChangeAspect="1"/>
+          </p:cNvPicPr>
+          <p:nvPr/>
+        </p:nvPicPr>
+        <p:blipFill>
+          <a:blip r:embed="rId3"/>
+          <a:stretch>
+            <a:fillRect/>
+          </a:stretch>
+        </p:blipFill>
+        <p:spPr>
+          <a:xfrm>
+            <a:off x="838200" y="11582400"/>
+            <a:ext cx="438150" cy="438150"/>
+          </a:xfrm>
+          <a:prstGeom prst="rect">
+            <a:avLst/>
+          </a:prstGeom>
+        </p:spPr>
+      </p:pic>
+      <p:sp>
+        <p:nvSpPr>
+          <p:cNvPr id="15" name="TextBox 14"/>
           <p:cNvSpPr txBox="1"/>
           <p:nvPr/>
         </p:nvSpPr>

</xml_diff>

<commit_message>
La foto a sangre se recorta al slide antes de ir al PPTX
Canva mostraba el slide 1 con la imagen corrida y con pedazos del slide
siguiente: al capturar el elemento se tomaba tambien lo que queda fuera
del slide, que el navegador recorta con overflow:hidden. Ahora se
esconde el texto y se captura la ventana exacta del slide (full_page,
si no el recorte se corta en el alto de la ventana) y va en JPEG.

Co-Authored-By: Claude Opus 5 <noreply@anthropic.com>
</commit_message>
<xml_diff>
--- a/contenido/carruseles/04-danibox/editable-canva.pptx
+++ b/contenido/carruseles/04-danibox/editable-canva.pptx
@@ -3101,7 +3101,7 @@
       <p:grpSpPr/>
       <p:pic>
         <p:nvPicPr>
-          <p:cNvPr id="2" name="Picture 1" descr="image.png"/>
+          <p:cNvPr id="2" name="Picture 1" descr="image.jpg"/>
           <p:cNvPicPr>
             <a:picLocks noChangeAspect="1"/>
           </p:cNvPicPr>
@@ -3115,8 +3115,8 @@
         </p:blipFill>
         <p:spPr>
           <a:xfrm>
-            <a:off x="-838200" y="-838200"/>
-            <a:ext cx="11963400" cy="14535150"/>
+            <a:off x="0" y="0"/>
+            <a:ext cx="10287000" cy="12858750"/>
           </a:xfrm>
           <a:prstGeom prst="rect">
             <a:avLst/>

</xml_diff>